<commit_message>
fix: overlapping labels, button colors, truncated text fields
</commit_message>
<xml_diff>
--- a/output_polarity_map_full.pptx
+++ b/output_polarity_map_full.pptx
@@ -14082,11 +14082,7 @@
           <a:bodyPr/>
           <a:lstStyle/>
           <a:p>
-            <a:pPr lvl="0"/>
-            <a:r>
-              <a:rPr lang="de-DE" dirty="0" sz="1200"/>
-              <a:t>Integrationserfolg durch vertrauensvolle und kritikfähige Vorstandskultur.</a:t>
-            </a:r>
+            <a:endParaRPr lang="de-DE"/>
           </a:p>
         </p:txBody>
       </p:sp>
@@ -14111,11 +14107,7 @@
           <a:bodyPr/>
           <a:lstStyle/>
           <a:p>
-            <a:pPr lvl="0"/>
-            <a:r>
-              <a:rPr lang="de-DE" dirty="0" sz="1200"/>
-              <a:t>Die Organisation wird durch ungelöste Kulturkonflikte handlungsunfähig.</a:t>
-            </a:r>
+            <a:endParaRPr lang="de-DE"/>
           </a:p>
         </p:txBody>
       </p:sp>
@@ -14140,11 +14132,7 @@
           <a:bodyPr/>
           <a:lstStyle/>
           <a:p>
-            <a:pPr lvl="0"/>
-            <a:r>
-              <a:rPr lang="de-DE" dirty="0" sz="1200"/>
-              <a:t>Tragfähige Beziehungen</a:t>
-            </a:r>
+            <a:endParaRPr lang="de-DE" dirty="0"/>
           </a:p>
         </p:txBody>
       </p:sp>
@@ -14169,11 +14157,7 @@
           <a:bodyPr/>
           <a:lstStyle/>
           <a:p>
-            <a:pPr lvl="0"/>
-            <a:r>
-              <a:rPr lang="de-DE" dirty="0" sz="1200"/>
-              <a:t>Klarheit und Kritikfähigkeit</a:t>
-            </a:r>
+            <a:endParaRPr lang="de-DE" dirty="0"/>
           </a:p>
         </p:txBody>
       </p:sp>
@@ -14203,7 +14187,7 @@
             </a:pPr>
             <a:r>
               <a:rPr lang="de-DE" dirty="0" sz="1100"/>
-              <a:t>psychologische Sicherheit ermöglicht offene Gespräche</a:t>
+              <a:t/>
             </a:r>
           </a:p>
           <a:p>
@@ -14212,7 +14196,7 @@
             </a:pPr>
             <a:r>
               <a:rPr lang="de-DE" dirty="0" sz="1100"/>
-              <a:t>Vertrauen beschleunigt Entscheidungsprozesse</a:t>
+              <a:t/>
             </a:r>
           </a:p>
           <a:p>
@@ -14221,7 +14205,7 @@
             </a:pPr>
             <a:r>
               <a:rPr lang="de-DE" dirty="0" sz="1100"/>
-              <a:t>Teamatmosphäre fördert konstruktive Lösungen</a:t>
+              <a:t/>
             </a:r>
           </a:p>
         </p:txBody>
@@ -14252,7 +14236,7 @@
             </a:pPr>
             <a:r>
               <a:rPr lang="de-DE" dirty="0" sz="1100"/>
-              <a:t>kritische Themen werden nicht angesprochen</a:t>
+              <a:t/>
             </a:r>
           </a:p>
           <a:p>
@@ -14261,7 +14245,7 @@
             </a:pPr>
             <a:r>
               <a:rPr lang="de-DE" dirty="0" sz="1100"/>
-              <a:t>fehlende Weiterentwicklung führt zu Stillstand</a:t>
+              <a:t/>
             </a:r>
           </a:p>
           <a:p>
@@ -14270,7 +14254,7 @@
             </a:pPr>
             <a:r>
               <a:rPr lang="de-DE" dirty="0" sz="1100"/>
-              <a:t>Gruppenkonsens verhindert notwendige Veränderungen</a:t>
+              <a:t/>
             </a:r>
           </a:p>
         </p:txBody>
@@ -14301,7 +14285,7 @@
             </a:pPr>
             <a:r>
               <a:rPr lang="de-DE" dirty="0" sz="1100"/>
-              <a:t>blinde Flecken werden systematisch aufgedeckt</a:t>
+              <a:t/>
             </a:r>
           </a:p>
           <a:p>
@@ -14310,7 +14294,7 @@
             </a:pPr>
             <a:r>
               <a:rPr lang="de-DE" dirty="0" sz="1100"/>
-              <a:t>kontinuierliches Lernen verbessert Prozesse</a:t>
+              <a:t/>
             </a:r>
           </a:p>
           <a:p>
@@ -14319,7 +14303,7 @@
             </a:pPr>
             <a:r>
               <a:rPr lang="de-DE" dirty="0" sz="1100"/>
-              <a:t>Weiterentwicklung sichert Zukunftsfähigkeit</a:t>
+              <a:t/>
             </a:r>
           </a:p>
         </p:txBody>
@@ -14350,7 +14334,7 @@
             </a:pPr>
             <a:r>
               <a:rPr lang="de-DE" dirty="0" sz="1100"/>
-              <a:t>psychologische Sicherheit geht verloren</a:t>
+              <a:t/>
             </a:r>
           </a:p>
           <a:p>
@@ -14359,7 +14343,7 @@
             </a:pPr>
             <a:r>
               <a:rPr lang="de-DE" dirty="0" sz="1100"/>
-              <a:t>Misstrauen blockiert offene Kommunikation</a:t>
+              <a:t/>
             </a:r>
           </a:p>
           <a:p>
@@ -14368,7 +14352,7 @@
             </a:pPr>
             <a:r>
               <a:rPr lang="de-DE" dirty="0" sz="1100"/>
-              <a:t>Teamatmosphäre leidet unter ständiger Kritik</a:t>
+              <a:t/>
             </a:r>
           </a:p>
         </p:txBody>
@@ -14399,7 +14383,7 @@
             </a:pPr>
             <a:r>
               <a:rPr lang="de-DE" dirty="0" sz="1100"/>
-              <a:t>regelmäßige informelle Vorstandstreffen etablieren</a:t>
+              <a:t/>
             </a:r>
           </a:p>
           <a:p>
@@ -14408,7 +14392,7 @@
             </a:pPr>
             <a:r>
               <a:rPr lang="de-DE" dirty="0" sz="1100"/>
-              <a:t>gemeinsame Erfolge bewusst feiern und würdigen</a:t>
+              <a:t/>
             </a:r>
           </a:p>
           <a:p>
@@ -14417,7 +14401,7 @@
             </a:pPr>
             <a:r>
               <a:rPr lang="de-DE" dirty="0" sz="1100"/>
-              <a:t>Vertrauensübungen in Klausurtagungen integrieren</a:t>
+              <a:t/>
             </a:r>
           </a:p>
         </p:txBody>
@@ -14448,7 +14432,7 @@
             </a:pPr>
             <a:r>
               <a:rPr lang="de-DE" dirty="0" sz="1100"/>
-              <a:t>kritische Compliance-Themen werden nicht mehr angesprochen</a:t>
+              <a:t/>
             </a:r>
           </a:p>
           <a:p>
@@ -14457,7 +14441,7 @@
             </a:pPr>
             <a:r>
               <a:rPr lang="de-DE" dirty="0" sz="1100"/>
-              <a:t>Entscheidungen werden ohne echte Diskussion getroffen</a:t>
+              <a:t/>
             </a:r>
           </a:p>
           <a:p>
@@ -14466,7 +14450,7 @@
             </a:pPr>
             <a:r>
               <a:rPr lang="de-DE" dirty="0" sz="1100"/>
-              <a:t>externe Berater melden fehlende Offenheit zurück</a:t>
+              <a:t/>
             </a:r>
           </a:p>
         </p:txBody>
@@ -14497,7 +14481,7 @@
             </a:pPr>
             <a:r>
               <a:rPr lang="de-DE" dirty="0" sz="1100"/>
-              <a:t>strukturierte Kritikrunden mit klaren Regeln einführen</a:t>
+              <a:t/>
             </a:r>
           </a:p>
           <a:p>
@@ -14506,7 +14490,7 @@
             </a:pPr>
             <a:r>
               <a:rPr lang="de-DE" dirty="0" sz="1100"/>
-              <a:t>externe Sparringspartner für blinde Flecken einladen</a:t>
+              <a:t/>
             </a:r>
           </a:p>
           <a:p>
@@ -14515,7 +14499,7 @@
             </a:pPr>
             <a:r>
               <a:rPr lang="de-DE" dirty="0" sz="1100"/>
-              <a:t>konstruktive Konfliktkultur gezielt trainieren</a:t>
+              <a:t/>
             </a:r>
           </a:p>
         </p:txBody>
@@ -14546,7 +14530,7 @@
             </a:pPr>
             <a:r>
               <a:rPr lang="de-DE" dirty="0" sz="1100"/>
-              <a:t>Vorstandsmitglieder meiden gemeinsame Termine</a:t>
+              <a:t/>
             </a:r>
           </a:p>
           <a:p>
@@ -14555,7 +14539,7 @@
             </a:pPr>
             <a:r>
               <a:rPr lang="de-DE" dirty="0" sz="1100"/>
-              <a:t>Entscheidungen werden in Kleingruppen vorbereitet</a:t>
+              <a:t/>
             </a:r>
           </a:p>
           <a:p>
@@ -14564,7 +14548,7 @@
             </a:pPr>
             <a:r>
               <a:rPr lang="de-DE" dirty="0" sz="1100"/>
-              <a:t>Mitarbeiter berichten von spürbaren Spannungen</a:t>
+              <a:t/>
             </a:r>
           </a:p>
         </p:txBody>

</xml_diff>

<commit_message>
feat: update CLAUDE.md and shared.py
</commit_message>
<xml_diff>
--- a/output_polarity_map_full.pptx
+++ b/output_polarity_map_full.pptx
@@ -14085,7 +14085,7 @@
             <a:pPr lvl="0"/>
             <a:r>
               <a:rPr lang="de-DE" dirty="0" sz="1200"/>
-              <a:t>Ganzheitliche Intelligenz für nachhaltigen Lebens- und Arbeitserfolg.</a:t>
+              <a:t>Ganzheitliche Leistungsfähigkeit durch balancierte Intelligenzen</a:t>
             </a:r>
           </a:p>
         </p:txBody>
@@ -14114,7 +14114,7 @@
             <a:pPr lvl="0"/>
             <a:r>
               <a:rPr lang="de-DE" dirty="0" sz="1200"/>
-              <a:t>Die Organisation scheitert an einseitiger Intelligenznutzung.</a:t>
+              <a:t>Einseitige Talententwicklung führt zu organisationaler Stagnation</a:t>
             </a:r>
           </a:p>
         </p:txBody>
@@ -14143,7 +14143,7 @@
             <a:pPr lvl="0"/>
             <a:r>
               <a:rPr lang="de-DE" dirty="0" sz="1200"/>
-              <a:t>Emotionale und soziale Intelligenz</a:t>
+              <a:t>Kognitive Intelligenz &amp; Fachwissen</a:t>
             </a:r>
           </a:p>
         </p:txBody>
@@ -14172,7 +14172,7 @@
             <a:pPr lvl="0"/>
             <a:r>
               <a:rPr lang="de-DE" dirty="0" sz="1200"/>
-              <a:t>Kognitive Intelligenz</a:t>
+              <a:t>Emotionale Intelligenz &amp; soziale Kompetenz</a:t>
             </a:r>
           </a:p>
         </p:txBody>
@@ -14203,7 +14203,7 @@
             </a:pPr>
             <a:r>
               <a:rPr lang="de-DE" dirty="0" sz="1100"/>
-              <a:t>Teams arbeiten vertrauensvoll und konfliktfähig zusammen</a:t>
+              <a:t>komplexe Problemlösungen werden systematisch erarbeitet</a:t>
             </a:r>
           </a:p>
           <a:p>
@@ -14212,7 +14212,7 @@
             </a:pPr>
             <a:r>
               <a:rPr lang="de-DE" dirty="0" sz="1100"/>
-              <a:t>Führungskräfte regulieren Emotionen in Stresssituationen souverän</a:t>
+              <a:t>fachliche Expertise sichert fundierte Entscheidungen</a:t>
             </a:r>
           </a:p>
           <a:p>
@@ -14221,7 +14221,7 @@
             </a:pPr>
             <a:r>
               <a:rPr lang="de-DE" dirty="0" sz="1100"/>
-              <a:t>Mitarbeitende bauen tragfähige berufliche Netzwerke auf</a:t>
+              <a:t>objektive Leistungsmessungen schaffen klare Standards</a:t>
             </a:r>
           </a:p>
         </p:txBody>
@@ -14252,7 +14252,7 @@
             </a:pPr>
             <a:r>
               <a:rPr lang="de-DE" dirty="0" sz="1100"/>
-              <a:t>Analytische Tiefe fehlt bei komplexen Sachfragen</a:t>
+              <a:t>Arbeitsleistung bleibt unter Potenzial</a:t>
             </a:r>
           </a:p>
           <a:p>
@@ -14261,7 +14261,7 @@
             </a:pPr>
             <a:r>
               <a:rPr lang="de-DE" dirty="0" sz="1100"/>
-              <a:t>Emotionale Dynamiken überlagern rationale Entscheidungsfindung</a:t>
+              <a:t>zwischenmenschliche Spannungen eskalieren ungelöst</a:t>
             </a:r>
           </a:p>
           <a:p>
@@ -14270,7 +14270,7 @@
             </a:pPr>
             <a:r>
               <a:rPr lang="de-DE" dirty="0" sz="1100"/>
-              <a:t>Technische Innovationen bleiben hinter Möglichkeiten zurück</a:t>
+              <a:t>Führungsqualität leidet unter fehlender Empathie</a:t>
             </a:r>
           </a:p>
         </p:txBody>
@@ -14301,7 +14301,7 @@
             </a:pPr>
             <a:r>
               <a:rPr lang="de-DE" dirty="0" sz="1100"/>
-              <a:t>Komplexe Probleme werden analytisch durchdrungen</a:t>
+              <a:t>Teams kooperieren vertrauensvoll und produktiv</a:t>
             </a:r>
           </a:p>
           <a:p>
@@ -14310,7 +14310,7 @@
             </a:pPr>
             <a:r>
               <a:rPr lang="de-DE" dirty="0" sz="1100"/>
-              <a:t>Entscheidungen basieren auf validierten Datenanalysen</a:t>
+              <a:t>Führungskräfte regulieren Konflikte konstruktiv</a:t>
             </a:r>
           </a:p>
           <a:p>
@@ -14319,7 +14319,7 @@
             </a:pPr>
             <a:r>
               <a:rPr lang="de-DE" dirty="0" sz="1100"/>
-              <a:t>Fachliche Exzellenz prägt die Arbeitsqualität</a:t>
+              <a:t>Mitarbeitende bewältigen Stress adaptiv</a:t>
             </a:r>
           </a:p>
         </p:txBody>
@@ -14350,7 +14350,7 @@
             </a:pPr>
             <a:r>
               <a:rPr lang="de-DE" dirty="0" sz="1100"/>
-              <a:t>Teamkonflikte eskalieren durch fehlende Empathie</a:t>
+              <a:t>fachliche Glaubwürdigkeit geht verloren</a:t>
             </a:r>
           </a:p>
           <a:p>
@@ -14359,7 +14359,7 @@
             </a:pPr>
             <a:r>
               <a:rPr lang="de-DE" dirty="0" sz="1100"/>
-              <a:t>Führungskräfte scheitern an zwischenmenschlichen Herausforderungen</a:t>
+              <a:t>Entscheidungen basieren auf Oberflächlichkeit</a:t>
             </a:r>
           </a:p>
           <a:p>
@@ -14368,7 +14368,7 @@
             </a:pPr>
             <a:r>
               <a:rPr lang="de-DE" dirty="0" sz="1100"/>
-              <a:t>Mitarbeiterbindung leidet unter rein leistungsorientierter Kultur</a:t>
+              <a:t>objektive Leistungsbewertung wird unmöglich</a:t>
             </a:r>
           </a:p>
         </p:txBody>
@@ -14399,7 +14399,7 @@
             </a:pPr>
             <a:r>
               <a:rPr lang="de-DE" dirty="0" sz="1100"/>
-              <a:t>Emotionale Intelligenz-Trainings für alle Führungsebenen etablieren</a:t>
+              <a:t>Fachtrainings und Zertifizierungsprogramme systematisch ausbauen</a:t>
             </a:r>
           </a:p>
           <a:p>
@@ -14408,7 +14408,7 @@
             </a:pPr>
             <a:r>
               <a:rPr lang="de-DE" dirty="0" sz="1100"/>
-              <a:t>360-Grad-Feedback zu sozialen Kompetenzen implementieren</a:t>
+              <a:t>Wissensmanagement-Systeme für Expertise-Transfer implementieren</a:t>
             </a:r>
           </a:p>
           <a:p>
@@ -14417,7 +14417,7 @@
             </a:pPr>
             <a:r>
               <a:rPr lang="de-DE" dirty="0" sz="1100"/>
-              <a:t>Teamreflexionsformate für emotionale Dynamiken einführen</a:t>
+              <a:t>Mentoring-Programme für kognitive Problemlösungskompetenz etablieren</a:t>
             </a:r>
           </a:p>
         </p:txBody>
@@ -14448,7 +14448,7 @@
             </a:pPr>
             <a:r>
               <a:rPr lang="de-DE" dirty="0" sz="1100"/>
-              <a:t>Sachentscheidungen werden zunehmend personalisiert</a:t>
+              <a:t>Mitarbeiterfeedback zeigt mangelnde Teamdynamik</a:t>
             </a:r>
           </a:p>
           <a:p>
@@ -14457,7 +14457,7 @@
             </a:pPr>
             <a:r>
               <a:rPr lang="de-DE" dirty="0" sz="1100"/>
-              <a:t>Analytische Berichte verlieren an Detailtiefe</a:t>
+              <a:t>Führungskräfte werden als distanziert wahrgenommen</a:t>
             </a:r>
           </a:p>
           <a:p>
@@ -14466,7 +14466,7 @@
             </a:pPr>
             <a:r>
               <a:rPr lang="de-DE" dirty="0" sz="1100"/>
-              <a:t>Fachliche Standards werden zugunsten von Harmonie aufgeweicht</a:t>
+              <a:t>Konfliktlösungszeiten verlängern sich messbar</a:t>
             </a:r>
           </a:p>
         </p:txBody>
@@ -14497,7 +14497,7 @@
             </a:pPr>
             <a:r>
               <a:rPr lang="de-DE" dirty="0" sz="1100"/>
-              <a:t>Systematische Weiterbildung in analytischen Methoden anbieten</a:t>
+              <a:t>EQ-Assessments in Personalentwicklung integrieren</a:t>
             </a:r>
           </a:p>
           <a:p>
@@ -14506,7 +14506,7 @@
             </a:pPr>
             <a:r>
               <a:rPr lang="de-DE" dirty="0" sz="1100"/>
-              <a:t>Datenbasierte Entscheidungsprozesse standardisieren</a:t>
+              <a:t>Teambuilding-Formate für Vertrauensaufbau durchführen</a:t>
             </a:r>
           </a:p>
           <a:p>
@@ -14515,7 +14515,7 @@
             </a:pPr>
             <a:r>
               <a:rPr lang="de-DE" dirty="0" sz="1100"/>
-              <a:t>Fachliche Exzellenzprogramme für Spezialisten entwickeln</a:t>
+              <a:t>Führungskräfte-Coaching für emotionale Kompetenz anbieten</a:t>
             </a:r>
           </a:p>
         </p:txBody>
@@ -14546,7 +14546,7 @@
             </a:pPr>
             <a:r>
               <a:rPr lang="de-DE" dirty="0" sz="1100"/>
-              <a:t>Fluktuation steigt trotz hoher fachlicher Performance</a:t>
+              <a:t>Fachliche Fehlerquoten steigen kontinuierlich</a:t>
             </a:r>
           </a:p>
           <a:p>
@@ -14555,7 +14555,7 @@
             </a:pPr>
             <a:r>
               <a:rPr lang="de-DE" dirty="0" sz="1100"/>
-              <a:t>Teamkonflikte häufen sich und bleiben ungelöst</a:t>
+              <a:t>Experten verlassen die Organisation häufiger</a:t>
             </a:r>
           </a:p>
           <a:p>
@@ -14564,7 +14564,7 @@
             </a:pPr>
             <a:r>
               <a:rPr lang="de-DE" dirty="0" sz="1100"/>
-              <a:t>Führungskräfte werden primär nach IQ ausgewählt</a:t>
+              <a:t>Innovationsrate sinkt trotz guter Stimmung</a:t>
             </a:r>
           </a:p>
         </p:txBody>

</xml_diff>